<commit_message>
feat(auth): add Connect Wallet, email OTP login, and JWT auth flow
- Connect Wallet button with eth_requestAccounts auto-fills address
- Email OTP + Magic Link login with 6-digit codes
- Wallet/cryptographic signing verification explained in UI
- JWT auth for protected API routes (nonce → personal_sign → JWT)
- Login page with Wallet/Email toggle (email default)
- types/ethereum.d.ts for MetaMask EIP-1193 type declarations
- lib/email.ts + lib/email-wallets.ts for email delivery
- lib/auth-client.ts for browser JWT storage
- 'Open Dashboard' CTAs across landing page and sidebar
- Deployer wallet 0xB70f... granted COOP_ROLE
</commit_message>
<xml_diff>
--- a/pitch-deck.pptx
+++ b/pitch-deck.pptx
@@ -4422,7 +4422,7 @@
               </a:defRPr>
             </a:pPr>
             <a:r>
-              <a:t>• No parallel database</a:t>
+              <a:t>• No parallel database — MAAIF data exclusivity</a:t>
             </a:r>
           </a:p>
         </p:txBody>
@@ -4764,201 +4764,90 @@
           </a:bodyPr>
           <a:lstStyle/>
           <a:p>
-            <a:pPr>
-              <a:spcAft>
-                <a:spcPts val="1200"/>
-              </a:spcAft>
-              <a:defRPr sz="1800">
-                <a:solidFill>
-                  <a:srgbClr val="1A3557"/>
-                </a:solidFill>
-                <a:latin typeface="Inter"/>
-              </a:defRPr>
-            </a:pPr>
-            <a:r>
+            <a:r>
+              <a:rPr/>
               <a:t>Revenue model:</a:t>
             </a:r>
           </a:p>
           <a:p>
-            <a:pPr>
-              <a:spcAft>
-                <a:spcPts val="1200"/>
-              </a:spcAft>
-              <a:defRPr sz="1800">
-                <a:solidFill>
-                  <a:srgbClr val="1A3557"/>
-                </a:solidFill>
-                <a:latin typeface="Inter"/>
-              </a:defRPr>
-            </a:pPr>
-            <a:r>
+            <a:r>
+              <a:rPr/>
               <a:t>• 4% APR protocol fee on all loans</a:t>
             </a:r>
           </a:p>
           <a:p>
-            <a:pPr>
-              <a:spcAft>
-                <a:spcPts val="1200"/>
-              </a:spcAft>
-              <a:defRPr sz="1800">
-                <a:solidFill>
-                  <a:srgbClr val="1A3557"/>
-                </a:solidFill>
-                <a:latin typeface="Inter"/>
-              </a:defRPr>
-            </a:pPr>
-            <a:r>
+            <a:r>
+              <a:rPr/>
               <a:t>• 2% credit loss reserve</a:t>
             </a:r>
           </a:p>
           <a:p>
-            <a:pPr>
-              <a:spcAft>
-                <a:spcPts val="1200"/>
-              </a:spcAft>
-              <a:defRPr sz="1800">
-                <a:solidFill>
-                  <a:srgbClr val="1A3557"/>
-                </a:solidFill>
-                <a:latin typeface="Inter"/>
-              </a:defRPr>
-            </a:pPr>
-            <a:r>
+            <a:r>
+              <a:rPr/>
               <a:t>• $25 per DDS generated (EUDR compliance per export batch)</a:t>
             </a:r>
           </a:p>
-          <a:p>
-            <a:pPr>
-              <a:spcAft>
-                <a:spcPts val="1200"/>
-              </a:spcAft>
-              <a:defRPr sz="1800">
-                <a:solidFill>
-                  <a:srgbClr val="1A3557"/>
-                </a:solidFill>
-                <a:latin typeface="Inter"/>
-              </a:defRPr>
-            </a:pPr>
-          </a:p>
-          <a:p>
-            <a:pPr>
-              <a:spcAft>
-                <a:spcPts val="1200"/>
-              </a:spcAft>
-              <a:defRPr sz="1800">
-                <a:solidFill>
-                  <a:srgbClr val="1A3557"/>
-                </a:solidFill>
-                <a:latin typeface="Inter"/>
-              </a:defRPr>
-            </a:pPr>
-            <a:r>
+          <a:p/>
+          <a:p>
+            <a:r>
+              <a:rPr/>
               <a:t>Adoption path:</a:t>
             </a:r>
           </a:p>
           <a:p>
-            <a:pPr>
-              <a:spcAft>
-                <a:spcPts val="1200"/>
-              </a:spcAft>
-              <a:defRPr sz="1800">
-                <a:solidFill>
-                  <a:srgbClr val="1A3557"/>
-                </a:solidFill>
-                <a:latin typeface="Inter"/>
-              </a:defRPr>
-            </a:pPr>
-            <a:r>
+            <a:r>
+              <a:rPr/>
               <a:t>• Phase 1: 10 co-ops (pilot)</a:t>
             </a:r>
           </a:p>
           <a:p>
-            <a:pPr>
-              <a:spcAft>
-                <a:spcPts val="1200"/>
-              </a:spcAft>
-              <a:defRPr sz="1800">
-                <a:solidFill>
-                  <a:srgbClr val="1A3557"/>
-                </a:solidFill>
-                <a:latin typeface="Inter"/>
-              </a:defRPr>
-            </a:pPr>
-            <a:r>
+            <a:r>
+              <a:rPr/>
               <a:t>• Phase 2: 100 co-ops (regional)</a:t>
             </a:r>
           </a:p>
           <a:p>
-            <a:pPr>
-              <a:spcAft>
-                <a:spcPts val="1200"/>
-              </a:spcAft>
-              <a:defRPr sz="1800">
-                <a:solidFill>
-                  <a:srgbClr val="1A3557"/>
-                </a:solidFill>
-                <a:latin typeface="Inter"/>
-              </a:defRPr>
-            </a:pPr>
-            <a:r>
+            <a:r>
+              <a:rPr/>
               <a:t>• Phase 3: 1,000 co-ops (national)</a:t>
             </a:r>
           </a:p>
           <a:p>
-            <a:pPr>
-              <a:spcAft>
-                <a:spcPts val="1200"/>
-              </a:spcAft>
-              <a:defRPr sz="1800">
-                <a:solidFill>
-                  <a:srgbClr val="1A3557"/>
-                </a:solidFill>
-                <a:latin typeface="Inter"/>
-              </a:defRPr>
-            </a:pPr>
-          </a:p>
-          <a:p>
-            <a:pPr>
-              <a:spcAft>
-                <a:spcPts val="1200"/>
-              </a:spcAft>
-              <a:defRPr sz="1800">
-                <a:solidFill>
-                  <a:srgbClr val="1A3557"/>
-                </a:solidFill>
-                <a:latin typeface="Inter"/>
-              </a:defRPr>
-            </a:pPr>
-            <a:r>
-              <a:t>Target: 1,000 cooperatives × $500K avg loan book = $500M TVL = $20M annual protocol revenue</a:t>
-            </a:r>
-          </a:p>
-          <a:p>
-            <a:pPr>
-              <a:spcAft>
-                <a:spcPts val="1200"/>
-              </a:spcAft>
-              <a:defRPr sz="1800">
-                <a:solidFill>
-                  <a:srgbClr val="1A3557"/>
-                </a:solidFill>
-                <a:latin typeface="Inter"/>
-              </a:defRPr>
-            </a:pPr>
-          </a:p>
-          <a:p>
-            <a:pPr>
-              <a:spcAft>
-                <a:spcPts val="1200"/>
-              </a:spcAft>
-              <a:defRPr sz="1800">
-                <a:solidFill>
-                  <a:srgbClr val="1A3557"/>
-                </a:solidFill>
-                <a:latin typeface="Inter"/>
-              </a:defRPr>
-            </a:pPr>
-            <a:r>
+            <a:r>
+              <a:rPr/>
+              <a:t>• MAAIF as distribution partner: 10-region rollout via SACCO network</a:t>
+            </a:r>
+          </a:p>
+          <a:p/>
+          <a:p>
+            <a:r>
+              <a:rPr/>
+              <a:t>Per farmer: $20/yr protocol revenue • ~$1/yr cost = ~$19/yr net</a:t>
+            </a:r>
+          </a:p>
+          <a:p>
+            <a:r>
+              <a:rPr/>
+              <a:t>• Batch-level: $25/DDS per export batch (EUDR compliance)</a:t>
+            </a:r>
+          </a:p>
+          <a:p/>
+          <a:p>
+            <a:r>
+              <a:rPr/>
+              <a:t>Target: 1,000 cooperatives × $500K avg loan book = $500M TVL</a:t>
+            </a:r>
+          </a:p>
+          <a:p>
+            <a:r>
+              <a:rPr/>
+              <a:t>= $20M annual protocol revenue</a:t>
+            </a:r>
+          </a:p>
+          <a:p/>
+          <a:p>
+            <a:r>
+              <a:rPr/>
               <a:t>Future: GPS-verified deforestation data enables carbon credit generation on Hedera</a:t>
             </a:r>
           </a:p>

</xml_diff>